<commit_message>
Tipo in grow => grown
</commit_message>
<xml_diff>
--- a/03_Selektion/03_Selektion.pptx
+++ b/03_Selektion/03_Selektion.pptx
@@ -230,7 +230,7 @@
           <a:p>
             <a:fld id="{BF336932-01FD-45AF-B110-84880AA37D65}" type="datetimeFigureOut">
               <a:rPr lang="de-AT" smtClean="0"/>
-              <a:t>07.10.2021</a:t>
+              <a:t>12.10.2021</a:t>
             </a:fld>
             <a:endParaRPr lang="de-AT"/>
           </a:p>
@@ -2091,7 +2091,13 @@
       </p:sp>
       <p:pic>
         <p:nvPicPr>
-          <p:cNvPr id="5" name="Grafik 4"/>
+          <p:cNvPr id="6" name="Grafik 5">
+            <a:extLst>
+              <a:ext uri="{FF2B5EF4-FFF2-40B4-BE49-F238E27FC236}">
+                <a16:creationId xmlns:a16="http://schemas.microsoft.com/office/drawing/2014/main" id="{6C81548B-F0F7-4B3F-8320-1BAFBA82CD5A}"/>
+              </a:ext>
+            </a:extLst>
+          </p:cNvPr>
           <p:cNvPicPr>
             <a:picLocks noChangeAspect="1"/>
           </p:cNvPicPr>
@@ -2105,8 +2111,8 @@
         </p:blipFill>
         <p:spPr>
           <a:xfrm>
-            <a:off x="492320" y="1412776"/>
-            <a:ext cx="7608071" cy="3125129"/>
+            <a:off x="457200" y="1556792"/>
+            <a:ext cx="8230752" cy="2448619"/>
           </a:xfrm>
           <a:prstGeom prst="rect">
             <a:avLst/>
@@ -12587,7 +12593,7 @@
           </a:ln>
           <a:extLst>
             <a:ext uri="{C572A759-6A51-4108-AA02-DFA0A04FC94B}">
-              <ma14:wrappingTextBoxFlag xmlns="" xmlns:ma14="http://schemas.microsoft.com/office/mac/drawingml/2011/main" val="1"/>
+              <ma14:wrappingTextBoxFlag xmlns:ma14="http://schemas.microsoft.com/office/mac/drawingml/2011/main" xmlns="" val="1"/>
             </a:ext>
           </a:extLst>
         </p:spPr>
@@ -12637,7 +12643,7 @@
           </a:ln>
           <a:extLst>
             <a:ext uri="{C572A759-6A51-4108-AA02-DFA0A04FC94B}">
-              <ma14:wrappingTextBoxFlag xmlns="" xmlns:ma14="http://schemas.microsoft.com/office/mac/drawingml/2011/main" val="1"/>
+              <ma14:wrappingTextBoxFlag xmlns:ma14="http://schemas.microsoft.com/office/mac/drawingml/2011/main" xmlns="" val="1"/>
             </a:ext>
           </a:extLst>
         </p:spPr>
@@ -12735,7 +12741,7 @@
           </a:ln>
           <a:extLst>
             <a:ext uri="{C572A759-6A51-4108-AA02-DFA0A04FC94B}">
-              <ma14:wrappingTextBoxFlag xmlns="" xmlns:ma14="http://schemas.microsoft.com/office/mac/drawingml/2011/main" val="1"/>
+              <ma14:wrappingTextBoxFlag xmlns:ma14="http://schemas.microsoft.com/office/mac/drawingml/2011/main" xmlns="" val="1"/>
             </a:ext>
           </a:extLst>
         </p:spPr>
@@ -12791,7 +12797,7 @@
           </a:ln>
           <a:extLst>
             <a:ext uri="{C572A759-6A51-4108-AA02-DFA0A04FC94B}">
-              <ma14:wrappingTextBoxFlag xmlns="" xmlns:ma14="http://schemas.microsoft.com/office/mac/drawingml/2011/main" val="1"/>
+              <ma14:wrappingTextBoxFlag xmlns:ma14="http://schemas.microsoft.com/office/mac/drawingml/2011/main" xmlns="" val="1"/>
             </a:ext>
           </a:extLst>
         </p:spPr>
@@ -12855,7 +12861,7 @@
           </a:ln>
           <a:extLst>
             <a:ext uri="{C572A759-6A51-4108-AA02-DFA0A04FC94B}">
-              <ma14:wrappingTextBoxFlag xmlns="" xmlns:ma14="http://schemas.microsoft.com/office/mac/drawingml/2011/main" val="1"/>
+              <ma14:wrappingTextBoxFlag xmlns:ma14="http://schemas.microsoft.com/office/mac/drawingml/2011/main" xmlns="" val="1"/>
             </a:ext>
           </a:extLst>
         </p:spPr>
@@ -12919,7 +12925,7 @@
           </a:ln>
           <a:extLst>
             <a:ext uri="{C572A759-6A51-4108-AA02-DFA0A04FC94B}">
-              <ma14:wrappingTextBoxFlag xmlns="" xmlns:ma14="http://schemas.microsoft.com/office/mac/drawingml/2011/main" val="1"/>
+              <ma14:wrappingTextBoxFlag xmlns:ma14="http://schemas.microsoft.com/office/mac/drawingml/2011/main" xmlns="" val="1"/>
             </a:ext>
           </a:extLst>
         </p:spPr>
@@ -13021,7 +13027,7 @@
           </a:ln>
           <a:extLst>
             <a:ext uri="{C572A759-6A51-4108-AA02-DFA0A04FC94B}">
-              <ma14:wrappingTextBoxFlag xmlns="" xmlns:ma14="http://schemas.microsoft.com/office/mac/drawingml/2011/main" val="1"/>
+              <ma14:wrappingTextBoxFlag xmlns:ma14="http://schemas.microsoft.com/office/mac/drawingml/2011/main" xmlns="" val="1"/>
             </a:ext>
           </a:extLst>
         </p:spPr>
@@ -13556,7 +13562,7 @@
           </a:ln>
           <a:extLst>
             <a:ext uri="{C572A759-6A51-4108-AA02-DFA0A04FC94B}">
-              <ma14:wrappingTextBoxFlag xmlns="" xmlns:ma14="http://schemas.microsoft.com/office/mac/drawingml/2011/main" val="1"/>
+              <ma14:wrappingTextBoxFlag xmlns:ma14="http://schemas.microsoft.com/office/mac/drawingml/2011/main" xmlns="" val="1"/>
             </a:ext>
           </a:extLst>
         </p:spPr>
@@ -13603,7 +13609,7 @@
           </a:ln>
           <a:extLst>
             <a:ext uri="{C572A759-6A51-4108-AA02-DFA0A04FC94B}">
-              <ma14:wrappingTextBoxFlag xmlns="" xmlns:ma14="http://schemas.microsoft.com/office/mac/drawingml/2011/main" val="1"/>
+              <ma14:wrappingTextBoxFlag xmlns:ma14="http://schemas.microsoft.com/office/mac/drawingml/2011/main" xmlns="" val="1"/>
             </a:ext>
           </a:extLst>
         </p:spPr>

</xml_diff>